<commit_message>
docs(deck): refresh four slides for shipped work
Slide 6 — The Proof
  Ablation header 8→12 bundles / 16→24 runs; Δ accuracy 0/5→5/5 becomes
  0/6→6/6; top-1 caption updated to 12/12 correct; Brier baseline
  0.352→0.287.

Slide 8 — Limitations
  Corpus size limitation flipped from 8 bundles → 12.

Slide 9 — Roadmap
  Full rewrite around the shipped nine-step ladder. Items 1 and 2 marked
  shipped (Sep 12–16 and Sep 14–19) covering policy engine + verification
  loop + CIS + dynamic LLM triage + OTLP adapter + corpus expansion.
  Items 3 and 4 remain: Live OTel Collector + shadow mode (≈2 weeks),
  Argo Rollouts execution + formal EIG (≈4 weeks).

Slide 12 — Appendix B (per-slice ablation)
  Table refreshed with the 12-bundle corpus counts: 4 ambiguous, 2
  adversarial red-herring, 1 cascading dependency, 2 resource exhaustion,
  3 deployment induced. All bundles 100% ON, 25% OFF.

Slides 1-5, 7, 10-11 unchanged.

Co-Authored-By: Claude Opus 4.7 <noreply@anthropic.com>
</commit_message>
<xml_diff>
--- a/demo/Incident_Commander_Presentation.pptx
+++ b/demo/Incident_Commander_Presentation.pptx
@@ -5961,7 +5961,7 @@
                 </a:solidFill>
                 <a:latin typeface="Calibri"/>
               </a:rPr>
-              <a:t>12 | APPENDIX B  ·  PER-SLICE ABLATION RESULTS</a:t>
+              <a:t>12 | APPENDIX B  ·  PER-SLICE ABLATION RESULTS  ·  12 BUNDLES, 24 RUNS</a:t>
             </a:r>
           </a:p>
         </p:txBody>
@@ -6074,7 +6074,7 @@
                 </a:solidFill>
                 <a:latin typeface="Calibri"/>
               </a:rPr>
-              <a:t>The full ablation, laid out. Deployment-induced is the easy case.</a:t>
+              <a:t>The full ablation on the wider corpus. Deployment-induced remains the easy case; hard slices still need probes.</a:t>
             </a:r>
           </a:p>
         </p:txBody>
@@ -6234,7 +6234,7 @@
                           </a:solidFill>
                           <a:latin typeface="Calibri"/>
                         </a:rPr>
-                        <a:t>3</a:t>
+                        <a:t>4</a:t>
                       </a:r>
                     </a:p>
                   </a:txBody>
@@ -6257,7 +6257,7 @@
                           </a:solidFill>
                           <a:latin typeface="Calibri"/>
                         </a:rPr>
-                        <a:t>100% (3/3)</a:t>
+                        <a:t>100% (4/4)</a:t>
                       </a:r>
                     </a:p>
                   </a:txBody>
@@ -6280,7 +6280,7 @@
                           </a:solidFill>
                           <a:latin typeface="Calibri"/>
                         </a:rPr>
-                        <a:t>0% (0/3)</a:t>
+                        <a:t>0% (0/4)</a:t>
                       </a:r>
                     </a:p>
                   </a:txBody>
@@ -6516,7 +6516,7 @@
                           </a:solidFill>
                           <a:latin typeface="Calibri"/>
                         </a:rPr>
-                        <a:t>1</a:t>
+                        <a:t>2</a:t>
                       </a:r>
                     </a:p>
                   </a:txBody>
@@ -6539,7 +6539,7 @@
                           </a:solidFill>
                           <a:latin typeface="Calibri"/>
                         </a:rPr>
-                        <a:t>100% (1/1)</a:t>
+                        <a:t>100% (2/2)</a:t>
                       </a:r>
                     </a:p>
                   </a:txBody>
@@ -6562,7 +6562,7 @@
                           </a:solidFill>
                           <a:latin typeface="Calibri"/>
                         </a:rPr>
-                        <a:t>0% (0/1)</a:t>
+                        <a:t>0% (0/2)</a:t>
                       </a:r>
                     </a:p>
                   </a:txBody>
@@ -6610,7 +6610,7 @@
                           </a:solidFill>
                           <a:latin typeface="Calibri"/>
                         </a:rPr>
-                        <a:t>1</a:t>
+                        <a:t>3</a:t>
                       </a:r>
                     </a:p>
                   </a:txBody>
@@ -6633,7 +6633,7 @@
                           </a:solidFill>
                           <a:latin typeface="Calibri"/>
                         </a:rPr>
-                        <a:t>100% (1/1)</a:t>
+                        <a:t>100% (3/3)</a:t>
                       </a:r>
                     </a:p>
                   </a:txBody>
@@ -6656,7 +6656,7 @@
                           </a:solidFill>
                           <a:latin typeface="Calibri"/>
                         </a:rPr>
-                        <a:t>100% (1/1)</a:t>
+                        <a:t>100% (3/3)</a:t>
                       </a:r>
                     </a:p>
                   </a:txBody>
@@ -6704,7 +6704,7 @@
                           </a:solidFill>
                           <a:latin typeface="Calibri"/>
                         </a:rPr>
-                        <a:t>8</a:t>
+                        <a:t>12</a:t>
                       </a:r>
                     </a:p>
                   </a:txBody>
@@ -6727,7 +6727,7 @@
                           </a:solidFill>
                           <a:latin typeface="Calibri"/>
                         </a:rPr>
-                        <a:t>100% (8/8)</a:t>
+                        <a:t>100% (12/12)</a:t>
                       </a:r>
                     </a:p>
                   </a:txBody>
@@ -6750,7 +6750,7 @@
                           </a:solidFill>
                           <a:latin typeface="Calibri"/>
                         </a:rPr>
-                        <a:t>12% (1/8)</a:t>
+                        <a:t>25% (3/12)</a:t>
                       </a:r>
                     </a:p>
                   </a:txBody>
@@ -6799,7 +6799,7 @@
                 </a:solidFill>
                 <a:latin typeface="Calibri"/>
               </a:rPr>
-              <a:t>For each of the 5 hard-slice bundles, OFF picks the wrong hypothesis; ON picks the right one.</a:t>
+              <a:t>For each of the 6 hard-slice bundles, OFF picks the wrong hypothesis; ON picks the right one.</a:t>
             </a:r>
           </a:p>
         </p:txBody>
@@ -12073,7 +12073,7 @@
                 </a:solidFill>
                 <a:latin typeface="Calibri"/>
               </a:rPr>
-              <a:t>06 | THE PROOF  ·  ABLATION ACROSS 8 BUNDLES, 16 RUNS</a:t>
+              <a:t>06 | THE PROOF  ·  ABLATION ACROSS 12 BUNDLES, 24 RUNS</a:t>
             </a:r>
           </a:p>
         </p:txBody>
@@ -12431,7 +12431,7 @@
                 </a:solidFill>
                 <a:latin typeface="Calibri"/>
               </a:rPr>
-              <a:t>0 % → 100 % (0/5 → 5/5)</a:t>
+              <a:t>0 % → 100 % (0/6 → 6/6)</a:t>
             </a:r>
           </a:p>
         </p:txBody>
@@ -12637,7 +12637,7 @@
                 </a:solidFill>
                 <a:latin typeface="Calibri"/>
               </a:rPr>
-              <a:t>8 / 8 bundles correct</a:t>
+              <a:t>12 / 12 bundles correct</a:t>
             </a:r>
           </a:p>
         </p:txBody>
@@ -13049,7 +13049,7 @@
                 </a:solidFill>
                 <a:latin typeface="Calibri"/>
               </a:rPr>
-              <a:t>baseline 0.352  ·  calibration</a:t>
+              <a:t>baseline 0.287  ·  calibration</a:t>
             </a:r>
           </a:p>
         </p:txBody>
@@ -15227,7 +15227,7 @@
                 </a:solidFill>
                 <a:latin typeface="Calibri"/>
               </a:rPr>
-              <a:t>8 authored bundles across 5 slices</a:t>
+              <a:t>12 authored bundles across 5 slices</a:t>
             </a:r>
           </a:p>
         </p:txBody>
@@ -16257,7 +16257,7 @@
                 </a:solidFill>
                 <a:latin typeface="Calibri"/>
               </a:rPr>
-              <a:t>09 | ROADMAP  ·  FOUR ITEMS, IN ORDER, TO THE FINAL PHASE</a:t>
+              <a:t>09 | ROADMAP  ·  SIX LADDER STAGES SHIPPED  ·  THREE REMAIN</a:t>
             </a:r>
           </a:p>
         </p:txBody>
@@ -16370,7 +16370,7 @@
                 </a:solidFill>
                 <a:latin typeface="Calibri"/>
               </a:rPr>
-              <a:t>Each item is scoped, sized, and unblocks the next.</a:t>
+              <a:t>The nine-step production ladder from docs/ROADMAP.md. Each remaining stage names its tool.</a:t>
             </a:r>
           </a:p>
         </p:txBody>
@@ -16453,7 +16453,7 @@
                 </a:solidFill>
                 <a:latin typeface="Calibri"/>
               </a:rPr>
-              <a:t>1</a:t>
+              <a:t>✓</a:t>
             </a:r>
           </a:p>
         </p:txBody>
@@ -16492,7 +16492,7 @@
                 </a:solidFill>
                 <a:latin typeface="Calibri"/>
               </a:rPr>
-              <a:t>Read-only Prometheus connector</a:t>
+              <a:t>Policy engine + verification loop + CIS</a:t>
             </a:r>
           </a:p>
         </p:txBody>
@@ -16531,7 +16531,7 @@
                 </a:solidFill>
                 <a:latin typeface="Calibri"/>
               </a:rPr>
-              <a:t>Turn fixture probes into live telemetry. Highest-leverage unlock for real-world evaluation.</a:t>
+              <a:t>OPA + Rego gate replaces the Approve button. Verification re-checks recovery; failure auto-reverts. Customer-Impact Score routes urgency without ever touching diagnosis.</a:t>
             </a:r>
           </a:p>
         </p:txBody>
@@ -16614,7 +16614,7 @@
                 </a:solidFill>
                 <a:latin typeface="Calibri"/>
               </a:rPr>
-              <a:t>≈ 1 week</a:t>
+              <a:t>shipped Sep 12–16</a:t>
             </a:r>
           </a:p>
         </p:txBody>
@@ -16732,7 +16732,7 @@
                 </a:solidFill>
                 <a:latin typeface="Calibri"/>
               </a:rPr>
-              <a:t>2</a:t>
+              <a:t>✓</a:t>
             </a:r>
           </a:p>
         </p:txBody>
@@ -16771,7 +16771,7 @@
                 </a:solidFill>
                 <a:latin typeface="Calibri"/>
               </a:rPr>
-              <a:t>Grow the corpus from real postmortems</a:t>
+              <a:t>Dynamic LLM triage + OTLP adapter + corpus 8→12</a:t>
             </a:r>
           </a:p>
         </p:txBody>
@@ -16810,7 +16810,7 @@
                 </a:solidFill>
                 <a:latin typeface="Calibri"/>
               </a:rPr>
-              <a:t>Target 30+ bundles across all five slices. Unlocks the first honest reliability diagram.</a:t>
+              <a:t>LLM generates hypotheses live from raw context with anti-hallucination filter. Spec-compliant OTLP JSON ingested via NiFi flow. Four new bundles exercise every new capability.</a:t>
             </a:r>
           </a:p>
         </p:txBody>
@@ -16893,7 +16893,7 @@
                 </a:solidFill>
                 <a:latin typeface="Calibri"/>
               </a:rPr>
-              <a:t>≈ 3 weeks</a:t>
+              <a:t>shipped Sep 14–19</a:t>
             </a:r>
           </a:p>
         </p:txBody>
@@ -17050,7 +17050,7 @@
                 </a:solidFill>
                 <a:latin typeface="Calibri"/>
               </a:rPr>
-              <a:t>LLM-driven probe interpretation</a:t>
+              <a:t>Live OTel Collector + shadow mode</a:t>
             </a:r>
           </a:p>
         </p:txBody>
@@ -17089,7 +17089,7 @@
                 </a:solidFill>
                 <a:latin typeface="Calibri"/>
               </a:rPr>
-              <a:t>Removes the three-family ceiling — system reads probe results for arbitrary signal types.</a:t>
+              <a:t>OTLP adapter is DONE — remaining work is wiring a real OpenTelemetry Collector to NiFi and adding the shadow-mode toggle that runs against real incidents without executing.</a:t>
             </a:r>
           </a:p>
         </p:txBody>
@@ -17329,7 +17329,7 @@
                 </a:solidFill>
                 <a:latin typeface="Calibri"/>
               </a:rPr>
-              <a:t>Container-orchestrated canary executor</a:t>
+              <a:t>Argo Rollouts execution + formal EIG</a:t>
             </a:r>
           </a:p>
         </p:txBody>
@@ -17368,7 +17368,7 @@
                 </a:solidFill>
                 <a:latin typeface="Calibri"/>
               </a:rPr>
-              <a:t>The intervention primitive fires live against a real service; safety envelope enforced by k8s.</a:t>
+              <a:t>Interventions fire against a real k8s canary controller (Argo Rollouts). Divergence heuristic in probe selection is replaced by formal Expected Information Gain (Chaloner &amp; Verdinelli).</a:t>
             </a:r>
           </a:p>
         </p:txBody>
@@ -17451,7 +17451,7 @@
                 </a:solidFill>
                 <a:latin typeface="Calibri"/>
               </a:rPr>
-              <a:t>≈ 3 weeks</a:t>
+              <a:t>≈ 4 weeks</a:t>
             </a:r>
           </a:p>
         </p:txBody>

</xml_diff>